<commit_message>
Demo login for judges; deck and brief updated for demo access
</commit_message>
<xml_diff>
--- a/docs/submission/Weekly-Posts-AI-Builder-Cup.pptx
+++ b/docs/submission/Weekly-Posts-AI-Builder-Cup.pptx
@@ -1060,7 +1060,7 @@
           <a:lstStyle/>
           <a:p>
             <a:r>
-              <a:t>These are measured from the codebase (full suite on 2026-10-18: 4,716 passed, 5 skipped). User-facing timings against the PRD targets (first post under 5 minutes, 3 design options under 15 seconds, render under 1.5 s, planted false facts flagged at least 95% of the time) are still to be measured.</a:t>
+              <a:t>These are measured from the codebase (full suite on 2026-10-18: 4,751 passed, 5 skipped). User-facing timings against the PRD targets (first post under 5 minutes, 3 design options under 15 seconds, render under 1.5 s, planted false facts flagged at least 95% of the time) are still to be measured.</a:t>
             </a:r>
           </a:p>
         </p:txBody>
@@ -1238,7 +1238,7 @@
           <a:lstStyle/>
           <a:p>
             <a:r>
-              <a:t>The live link is the deployed app. The GitHub repository is currently private; a public link is needed for submission.</a:t>
+              <a:t>Open the demo link and enter the access code: you are signed in to a working demo business (no email needed). You can create, edit, approve, schedule and publish posts, plan a week and see Ideas; account-level actions are locked in demo sessions. The 3-minute demo video shows the full flow on the live app, including Firestore live status in the Queue.</a:t>
             </a:r>
           </a:p>
         </p:txBody>
@@ -8964,7 +8964,7 @@
                 <a:cs typeface="Google Sans Flex"/>
                 <a:sym typeface="Google Sans Flex"/>
               </a:rPr>
-              <a:t>4,716</a:t>
+              <a:t>4,751</a:t>
             </a:r>
           </a:p>
           <a:p>
@@ -10203,16 +10203,13 @@
               <a:t>GitHub Public Repository: </a:t>
             </a:r>
             <a:r>
-              <a:rPr lang="en-GB" b="1">
-                <a:solidFill>
-                  <a:srgbClr val="ED561B"/>
-                </a:solidFill>
+              <a:rPr lang="en-GB">
                 <a:latin typeface="Google Sans Flex Medium"/>
                 <a:ea typeface="Google Sans Flex Medium"/>
                 <a:cs typeface="Google Sans Flex Medium"/>
                 <a:sym typeface="Google Sans Flex Medium"/>
               </a:rPr>
-              <a:t>[OWNER TO FILL]</a:t>
+              <a:t>github.com/quant-1729/weekly-posts</a:t>
             </a:r>
             <a:endParaRPr>
               <a:latin typeface="Google Sans Flex Medium"/>
@@ -10243,16 +10240,13 @@
               <a:t>Demo Video Link (3 Minutes): </a:t>
             </a:r>
             <a:r>
-              <a:rPr lang="en-GB" b="1">
-                <a:solidFill>
-                  <a:srgbClr val="ED561B"/>
-                </a:solidFill>
+              <a:rPr lang="en-GB">
                 <a:latin typeface="Google Sans Flex Medium"/>
                 <a:ea typeface="Google Sans Flex Medium"/>
                 <a:cs typeface="Google Sans Flex Medium"/>
                 <a:sym typeface="Google Sans Flex Medium"/>
               </a:rPr>
-              <a:t>[OWNER TO FILL]</a:t>
+              <a:t>[OWNER TO FILL: YouTube or Drive link]</a:t>
             </a:r>
             <a:endParaRPr>
               <a:latin typeface="Google Sans Flex Medium"/>
@@ -10310,7 +10304,48 @@
                 <a:sym typeface="Google Sans Flex"/>
                 <a:hlinkClick r:id="rId5"/>
               </a:rPr>
-              <a:t>https://weekly-posts-526531409571.australia-southeast1.run.app</a:t>
+              <a:t>https://weekly-posts-526531409571.australia-southeast1.run.app/demo</a:t>
+            </a:r>
+            <a:endParaRPr>
+              <a:latin typeface="Google Sans Flex Medium"/>
+              <a:ea typeface="Google Sans Flex Medium"/>
+              <a:cs typeface="Google Sans Flex Medium"/>
+              <a:sym typeface="Google Sans Flex Medium"/>
+            </a:endParaRPr>
+          </a:p>
+          <a:p>
+            <a:pPr indent="0" lvl="0" marL="457200" rtl="0" algn="l">
+              <a:spcBef>
+                <a:spcPts val="0"/>
+              </a:spcBef>
+              <a:spcAft>
+                <a:spcPts val="0"/>
+              </a:spcAft>
+              <a:buNone/>
+            </a:pPr>
+            <a:r>
+              <a:rPr sz="1300" b="0" lang="en-GB">
+                <a:solidFill>
+                  <a:srgbClr val="000000"/>
+                </a:solidFill>
+                <a:latin typeface="Google Sans Flex"/>
+                <a:ea typeface="Google Sans Flex"/>
+                <a:cs typeface="Google Sans Flex"/>
+                <a:sym typeface="Google Sans Flex"/>
+              </a:rPr>
+              <a:t>Access code: </a:t>
+            </a:r>
+            <a:r>
+              <a:rPr sz="1300" b="0" lang="en-GB">
+                <a:solidFill>
+                  <a:srgbClr val="000000"/>
+                </a:solidFill>
+                <a:latin typeface="Google Sans Flex"/>
+                <a:ea typeface="Google Sans Flex"/>
+                <a:cs typeface="Google Sans Flex"/>
+                <a:sym typeface="Google Sans Flex"/>
+              </a:rPr>
+              <a:t>provided in the submission form</a:t>
             </a:r>
             <a:endParaRPr>
               <a:latin typeface="Google Sans Flex Medium"/>
@@ -10402,7 +10437,7 @@
                 <a:cs typeface="Google Sans Flex"/>
                 <a:sym typeface="Google Sans Flex"/>
               </a:rPr>
-              <a:t>Scan for the live app</a:t>
+              <a:t>Scan to open the demo</a:t>
             </a:r>
           </a:p>
         </p:txBody>

</xml_diff>